<commit_message>
Phase 3 (WIP): continued data, API and setup work
Co-Authored-By: Claude Opus 5.5 <noreply@anthropic.com>
Claude-Session: https://claude.ai/code/session_01FkouT5fAgzdcE8NaiFmB4Y
</commit_message>
<xml_diff>
--- a/data/sharepoint/Harbourline-Operations/Procedures/Crew-Briefing-Deck.pptx
+++ b/data/sharepoint/Harbourline-Operations/Procedures/Crew-Briefing-Deck.pptx
@@ -651,7 +651,7 @@
           <a:lstStyle/>
           <a:p>
             <a:r>
-              <a:t>Keep this under 45 minutes. Leave time for questions at the end.</a:t>
+              <a:t>Keep this under 40 minutes. Leave time for questions at the end.</a:t>
             </a:r>
           </a:p>
         </p:txBody>
@@ -3922,7 +3922,7 @@
           <a:spcPct val="20000"/>
         </a:spcBef>
         <a:buFont typeface="Arial"/>
-        <a:buChar char="–"/>
+        <a:buChar char="•"/>
         <a:defRPr sz="2800" kern="1200">
           <a:solidFill>
             <a:schemeClr val="tx1"/>
@@ -3952,7 +3952,7 @@
           <a:spcPct val="20000"/>
         </a:spcBef>
         <a:buFont typeface="Arial"/>
-        <a:buChar char="–"/>
+        <a:buChar char="•"/>
         <a:defRPr sz="2000" kern="1200">
           <a:solidFill>
             <a:schemeClr val="tx1"/>
@@ -4157,7 +4157,12 @@
             <p:ph type="ctrTitle"/>
           </p:nvPr>
         </p:nvSpPr>
-        <p:spPr/>
+        <p:spPr>
+          <a:xfrm>
+            <a:off x="914400" y="2011680"/>
+            <a:ext cx="10360152" cy="1371600"/>
+          </a:xfrm>
+        </p:spPr>
         <p:txBody>
           <a:bodyPr/>
           <a:lstStyle/>
@@ -4178,7 +4183,12 @@
             <p:ph type="subTitle" idx="1"/>
           </p:nvPr>
         </p:nvSpPr>
-        <p:spPr/>
+        <p:spPr>
+          <a:xfrm>
+            <a:off x="914400" y="3566160"/>
+            <a:ext cx="10360152" cy="1280160"/>
+          </a:xfrm>
+        </p:spPr>
         <p:txBody>
           <a:bodyPr/>
           <a:lstStyle/>

</xml_diff>